<commit_message>
Remove obsolete skills and update local assets
</commit_message>
<xml_diff>
--- a/sample.pptx
+++ b/sample.pptx
@@ -5,11 +5,11 @@
     <p:sldMasterId id="2147483648" r:id="rId1"/>
   </p:sldMasterIdLst>
   <p:sldIdLst>
-    <p:sldId id="256" r:id="rId7"/>
-    <p:sldId id="257" r:id="rId8"/>
-    <p:sldId id="258" r:id="rId9"/>
+    <p:sldId id="256" r:id="rId2"/>
+    <p:sldId id="257" r:id="rId3"/>
+    <p:sldId id="258" r:id="rId4"/>
   </p:sldIdLst>
-  <p:sldSz cx="12191695" cy="6858000" type="screen4x3"/>
+  <p:sldSz cx="12192000" cy="6858000"/>
   <p:notesSz cx="6858000" cy="9144000"/>
   <p:defaultTextStyle>
     <a:defPPr>
@@ -106,6 +106,22 @@
       </a:defRPr>
     </a:lvl9pPr>
   </p:defaultTextStyle>
+  <p:extLst>
+    <p:ext uri="{EFAFB233-063F-42B5-8137-9DF3F51BA10A}">
+      <p15:sldGuideLst xmlns:p15="http://schemas.microsoft.com/office/powerpoint/2012/main">
+        <p15:guide id="1" orient="horz" pos="2160">
+          <p15:clr>
+            <a:srgbClr val="A4A3A4"/>
+          </p15:clr>
+        </p15:guide>
+        <p15:guide id="2" pos="2880">
+          <p15:clr>
+            <a:srgbClr val="A4A3A4"/>
+          </p15:clr>
+        </p15:guide>
+      </p15:sldGuideLst>
+    </p:ext>
+  </p:extLst>
 </p:presentation>
 </file>
 
@@ -147,10 +163,9 @@
           <a:lstStyle/>
           <a:p>
             <a:r>
-              <a:rPr lang="en-US" smtClean="0"/>
+              <a:rPr lang="en-US"/>
               <a:t>Click to edit Master title style</a:t>
             </a:r>
-            <a:endParaRPr lang="en-US"/>
           </a:p>
         </p:txBody>
       </p:sp>
@@ -266,10 +281,9 @@
           </a:lstStyle>
           <a:p>
             <a:r>
-              <a:rPr lang="en-US" smtClean="0"/>
+              <a:rPr lang="en-US"/>
               <a:t>Click to edit Master subtitle style</a:t>
             </a:r>
-            <a:endParaRPr lang="en-US"/>
           </a:p>
         </p:txBody>
       </p:sp>
@@ -290,7 +304,7 @@
           <a:p>
             <a:fld id="{5BCAD085-E8A6-8845-BD4E-CB4CCA059FC4}" type="datetimeFigureOut">
               <a:rPr lang="en-US" smtClean="0"/>
-              <a:t>1/27/13</a:t>
+              <a:t>6/4/2026</a:t>
             </a:fld>
             <a:endParaRPr lang="en-US"/>
           </a:p>
@@ -384,10 +398,9 @@
           <a:lstStyle/>
           <a:p>
             <a:r>
-              <a:rPr lang="en-US" smtClean="0"/>
+              <a:rPr lang="en-US"/>
               <a:t>Click to edit Master title style</a:t>
             </a:r>
-            <a:endParaRPr lang="en-US"/>
           </a:p>
         </p:txBody>
       </p:sp>
@@ -408,38 +421,37 @@
           <a:p>
             <a:pPr lvl="0"/>
             <a:r>
-              <a:rPr lang="en-US" smtClean="0"/>
+              <a:rPr lang="en-US"/>
               <a:t>Click to edit Master text styles</a:t>
             </a:r>
           </a:p>
           <a:p>
             <a:pPr lvl="1"/>
             <a:r>
-              <a:rPr lang="en-US" smtClean="0"/>
+              <a:rPr lang="en-US"/>
               <a:t>Second level</a:t>
             </a:r>
           </a:p>
           <a:p>
             <a:pPr lvl="2"/>
             <a:r>
-              <a:rPr lang="en-US" smtClean="0"/>
+              <a:rPr lang="en-US"/>
               <a:t>Third level</a:t>
             </a:r>
           </a:p>
           <a:p>
             <a:pPr lvl="3"/>
             <a:r>
-              <a:rPr lang="en-US" smtClean="0"/>
+              <a:rPr lang="en-US"/>
               <a:t>Fourth level</a:t>
             </a:r>
           </a:p>
           <a:p>
             <a:pPr lvl="4"/>
             <a:r>
-              <a:rPr lang="en-US" smtClean="0"/>
+              <a:rPr lang="en-US"/>
               <a:t>Fifth level</a:t>
             </a:r>
-            <a:endParaRPr lang="en-US"/>
           </a:p>
         </p:txBody>
       </p:sp>
@@ -460,7 +472,7 @@
           <a:p>
             <a:fld id="{5BCAD085-E8A6-8845-BD4E-CB4CCA059FC4}" type="datetimeFigureOut">
               <a:rPr lang="en-US" smtClean="0"/>
-              <a:t>1/27/13</a:t>
+              <a:t>6/4/2026</a:t>
             </a:fld>
             <a:endParaRPr lang="en-US"/>
           </a:p>
@@ -559,10 +571,9 @@
           <a:lstStyle/>
           <a:p>
             <a:r>
-              <a:rPr lang="en-US" smtClean="0"/>
+              <a:rPr lang="en-US"/>
               <a:t>Click to edit Master title style</a:t>
             </a:r>
-            <a:endParaRPr lang="en-US"/>
           </a:p>
         </p:txBody>
       </p:sp>
@@ -588,38 +599,37 @@
           <a:p>
             <a:pPr lvl="0"/>
             <a:r>
-              <a:rPr lang="en-US" smtClean="0"/>
+              <a:rPr lang="en-US"/>
               <a:t>Click to edit Master text styles</a:t>
             </a:r>
           </a:p>
           <a:p>
             <a:pPr lvl="1"/>
             <a:r>
-              <a:rPr lang="en-US" smtClean="0"/>
+              <a:rPr lang="en-US"/>
               <a:t>Second level</a:t>
             </a:r>
           </a:p>
           <a:p>
             <a:pPr lvl="2"/>
             <a:r>
-              <a:rPr lang="en-US" smtClean="0"/>
+              <a:rPr lang="en-US"/>
               <a:t>Third level</a:t>
             </a:r>
           </a:p>
           <a:p>
             <a:pPr lvl="3"/>
             <a:r>
-              <a:rPr lang="en-US" smtClean="0"/>
+              <a:rPr lang="en-US"/>
               <a:t>Fourth level</a:t>
             </a:r>
           </a:p>
           <a:p>
             <a:pPr lvl="4"/>
             <a:r>
-              <a:rPr lang="en-US" smtClean="0"/>
+              <a:rPr lang="en-US"/>
               <a:t>Fifth level</a:t>
             </a:r>
-            <a:endParaRPr lang="en-US"/>
           </a:p>
         </p:txBody>
       </p:sp>
@@ -640,7 +650,7 @@
           <a:p>
             <a:fld id="{5BCAD085-E8A6-8845-BD4E-CB4CCA059FC4}" type="datetimeFigureOut">
               <a:rPr lang="en-US" smtClean="0"/>
-              <a:t>1/27/13</a:t>
+              <a:t>6/4/2026</a:t>
             </a:fld>
             <a:endParaRPr lang="en-US"/>
           </a:p>
@@ -734,10 +744,9 @@
           <a:lstStyle/>
           <a:p>
             <a:r>
-              <a:rPr lang="en-US" smtClean="0"/>
+              <a:rPr lang="en-US"/>
               <a:t>Click to edit Master title style</a:t>
             </a:r>
-            <a:endParaRPr lang="en-US"/>
           </a:p>
         </p:txBody>
       </p:sp>
@@ -758,38 +767,37 @@
           <a:p>
             <a:pPr lvl="0"/>
             <a:r>
-              <a:rPr lang="en-US" smtClean="0"/>
+              <a:rPr lang="en-US"/>
               <a:t>Click to edit Master text styles</a:t>
             </a:r>
           </a:p>
           <a:p>
             <a:pPr lvl="1"/>
             <a:r>
-              <a:rPr lang="en-US" smtClean="0"/>
+              <a:rPr lang="en-US"/>
               <a:t>Second level</a:t>
             </a:r>
           </a:p>
           <a:p>
             <a:pPr lvl="2"/>
             <a:r>
-              <a:rPr lang="en-US" smtClean="0"/>
+              <a:rPr lang="en-US"/>
               <a:t>Third level</a:t>
             </a:r>
           </a:p>
           <a:p>
             <a:pPr lvl="3"/>
             <a:r>
-              <a:rPr lang="en-US" smtClean="0"/>
+              <a:rPr lang="en-US"/>
               <a:t>Fourth level</a:t>
             </a:r>
           </a:p>
           <a:p>
             <a:pPr lvl="4"/>
             <a:r>
-              <a:rPr lang="en-US" smtClean="0"/>
+              <a:rPr lang="en-US"/>
               <a:t>Fifth level</a:t>
             </a:r>
-            <a:endParaRPr lang="en-US"/>
           </a:p>
         </p:txBody>
       </p:sp>
@@ -810,7 +818,7 @@
           <a:p>
             <a:fld id="{5BCAD085-E8A6-8845-BD4E-CB4CCA059FC4}" type="datetimeFigureOut">
               <a:rPr lang="en-US" smtClean="0"/>
-              <a:t>1/27/13</a:t>
+              <a:t>6/4/2026</a:t>
             </a:fld>
             <a:endParaRPr lang="en-US"/>
           </a:p>
@@ -913,10 +921,9 @@
           </a:lstStyle>
           <a:p>
             <a:r>
-              <a:rPr lang="en-US" smtClean="0"/>
+              <a:rPr lang="en-US"/>
               <a:t>Click to edit Master title style</a:t>
             </a:r>
-            <a:endParaRPr lang="en-US"/>
           </a:p>
         </p:txBody>
       </p:sp>
@@ -1033,7 +1040,7 @@
           <a:p>
             <a:pPr lvl="0"/>
             <a:r>
-              <a:rPr lang="en-US" smtClean="0"/>
+              <a:rPr lang="en-US"/>
               <a:t>Click to edit Master text styles</a:t>
             </a:r>
           </a:p>
@@ -1056,7 +1063,7 @@
           <a:p>
             <a:fld id="{5BCAD085-E8A6-8845-BD4E-CB4CCA059FC4}" type="datetimeFigureOut">
               <a:rPr lang="en-US" smtClean="0"/>
-              <a:t>1/27/13</a:t>
+              <a:t>6/4/2026</a:t>
             </a:fld>
             <a:endParaRPr lang="en-US"/>
           </a:p>
@@ -1150,10 +1157,9 @@
           <a:lstStyle/>
           <a:p>
             <a:r>
-              <a:rPr lang="en-US" smtClean="0"/>
+              <a:rPr lang="en-US"/>
               <a:t>Click to edit Master title style</a:t>
             </a:r>
-            <a:endParaRPr lang="en-US"/>
           </a:p>
         </p:txBody>
       </p:sp>
@@ -1207,38 +1213,37 @@
           <a:p>
             <a:pPr lvl="0"/>
             <a:r>
-              <a:rPr lang="en-US" smtClean="0"/>
+              <a:rPr lang="en-US"/>
               <a:t>Click to edit Master text styles</a:t>
             </a:r>
           </a:p>
           <a:p>
             <a:pPr lvl="1"/>
             <a:r>
-              <a:rPr lang="en-US" smtClean="0"/>
+              <a:rPr lang="en-US"/>
               <a:t>Second level</a:t>
             </a:r>
           </a:p>
           <a:p>
             <a:pPr lvl="2"/>
             <a:r>
-              <a:rPr lang="en-US" smtClean="0"/>
+              <a:rPr lang="en-US"/>
               <a:t>Third level</a:t>
             </a:r>
           </a:p>
           <a:p>
             <a:pPr lvl="3"/>
             <a:r>
-              <a:rPr lang="en-US" smtClean="0"/>
+              <a:rPr lang="en-US"/>
               <a:t>Fourth level</a:t>
             </a:r>
           </a:p>
           <a:p>
             <a:pPr lvl="4"/>
             <a:r>
-              <a:rPr lang="en-US" smtClean="0"/>
+              <a:rPr lang="en-US"/>
               <a:t>Fifth level</a:t>
             </a:r>
-            <a:endParaRPr lang="en-US"/>
           </a:p>
         </p:txBody>
       </p:sp>
@@ -1292,38 +1297,37 @@
           <a:p>
             <a:pPr lvl="0"/>
             <a:r>
-              <a:rPr lang="en-US" smtClean="0"/>
+              <a:rPr lang="en-US"/>
               <a:t>Click to edit Master text styles</a:t>
             </a:r>
           </a:p>
           <a:p>
             <a:pPr lvl="1"/>
             <a:r>
-              <a:rPr lang="en-US" smtClean="0"/>
+              <a:rPr lang="en-US"/>
               <a:t>Second level</a:t>
             </a:r>
           </a:p>
           <a:p>
             <a:pPr lvl="2"/>
             <a:r>
-              <a:rPr lang="en-US" smtClean="0"/>
+              <a:rPr lang="en-US"/>
               <a:t>Third level</a:t>
             </a:r>
           </a:p>
           <a:p>
             <a:pPr lvl="3"/>
             <a:r>
-              <a:rPr lang="en-US" smtClean="0"/>
+              <a:rPr lang="en-US"/>
               <a:t>Fourth level</a:t>
             </a:r>
           </a:p>
           <a:p>
             <a:pPr lvl="4"/>
             <a:r>
-              <a:rPr lang="en-US" smtClean="0"/>
+              <a:rPr lang="en-US"/>
               <a:t>Fifth level</a:t>
             </a:r>
-            <a:endParaRPr lang="en-US"/>
           </a:p>
         </p:txBody>
       </p:sp>
@@ -1344,7 +1348,7 @@
           <a:p>
             <a:fld id="{5BCAD085-E8A6-8845-BD4E-CB4CCA059FC4}" type="datetimeFigureOut">
               <a:rPr lang="en-US" smtClean="0"/>
-              <a:t>1/27/13</a:t>
+              <a:t>6/4/2026</a:t>
             </a:fld>
             <a:endParaRPr lang="en-US"/>
           </a:p>
@@ -1442,10 +1446,9 @@
           </a:lstStyle>
           <a:p>
             <a:r>
-              <a:rPr lang="en-US" smtClean="0"/>
+              <a:rPr lang="en-US"/>
               <a:t>Click to edit Master title style</a:t>
             </a:r>
-            <a:endParaRPr lang="en-US"/>
           </a:p>
         </p:txBody>
       </p:sp>
@@ -1508,7 +1511,7 @@
           <a:p>
             <a:pPr lvl="0"/>
             <a:r>
-              <a:rPr lang="en-US" smtClean="0"/>
+              <a:rPr lang="en-US"/>
               <a:t>Click to edit Master text styles</a:t>
             </a:r>
           </a:p>
@@ -1564,38 +1567,37 @@
           <a:p>
             <a:pPr lvl="0"/>
             <a:r>
-              <a:rPr lang="en-US" smtClean="0"/>
+              <a:rPr lang="en-US"/>
               <a:t>Click to edit Master text styles</a:t>
             </a:r>
           </a:p>
           <a:p>
             <a:pPr lvl="1"/>
             <a:r>
-              <a:rPr lang="en-US" smtClean="0"/>
+              <a:rPr lang="en-US"/>
               <a:t>Second level</a:t>
             </a:r>
           </a:p>
           <a:p>
             <a:pPr lvl="2"/>
             <a:r>
-              <a:rPr lang="en-US" smtClean="0"/>
+              <a:rPr lang="en-US"/>
               <a:t>Third level</a:t>
             </a:r>
           </a:p>
           <a:p>
             <a:pPr lvl="3"/>
             <a:r>
-              <a:rPr lang="en-US" smtClean="0"/>
+              <a:rPr lang="en-US"/>
               <a:t>Fourth level</a:t>
             </a:r>
           </a:p>
           <a:p>
             <a:pPr lvl="4"/>
             <a:r>
-              <a:rPr lang="en-US" smtClean="0"/>
+              <a:rPr lang="en-US"/>
               <a:t>Fifth level</a:t>
             </a:r>
-            <a:endParaRPr lang="en-US"/>
           </a:p>
         </p:txBody>
       </p:sp>
@@ -1658,7 +1660,7 @@
           <a:p>
             <a:pPr lvl="0"/>
             <a:r>
-              <a:rPr lang="en-US" smtClean="0"/>
+              <a:rPr lang="en-US"/>
               <a:t>Click to edit Master text styles</a:t>
             </a:r>
           </a:p>
@@ -1714,38 +1716,37 @@
           <a:p>
             <a:pPr lvl="0"/>
             <a:r>
-              <a:rPr lang="en-US" smtClean="0"/>
+              <a:rPr lang="en-US"/>
               <a:t>Click to edit Master text styles</a:t>
             </a:r>
           </a:p>
           <a:p>
             <a:pPr lvl="1"/>
             <a:r>
-              <a:rPr lang="en-US" smtClean="0"/>
+              <a:rPr lang="en-US"/>
               <a:t>Second level</a:t>
             </a:r>
           </a:p>
           <a:p>
             <a:pPr lvl="2"/>
             <a:r>
-              <a:rPr lang="en-US" smtClean="0"/>
+              <a:rPr lang="en-US"/>
               <a:t>Third level</a:t>
             </a:r>
           </a:p>
           <a:p>
             <a:pPr lvl="3"/>
             <a:r>
-              <a:rPr lang="en-US" smtClean="0"/>
+              <a:rPr lang="en-US"/>
               <a:t>Fourth level</a:t>
             </a:r>
           </a:p>
           <a:p>
             <a:pPr lvl="4"/>
             <a:r>
-              <a:rPr lang="en-US" smtClean="0"/>
+              <a:rPr lang="en-US"/>
               <a:t>Fifth level</a:t>
             </a:r>
-            <a:endParaRPr lang="en-US"/>
           </a:p>
         </p:txBody>
       </p:sp>
@@ -1766,7 +1767,7 @@
           <a:p>
             <a:fld id="{5BCAD085-E8A6-8845-BD4E-CB4CCA059FC4}" type="datetimeFigureOut">
               <a:rPr lang="en-US" smtClean="0"/>
-              <a:t>1/27/13</a:t>
+              <a:t>6/4/2026</a:t>
             </a:fld>
             <a:endParaRPr lang="en-US"/>
           </a:p>
@@ -1860,10 +1861,9 @@
           <a:lstStyle/>
           <a:p>
             <a:r>
-              <a:rPr lang="en-US" smtClean="0"/>
+              <a:rPr lang="en-US"/>
               <a:t>Click to edit Master title style</a:t>
             </a:r>
-            <a:endParaRPr lang="en-US"/>
           </a:p>
         </p:txBody>
       </p:sp>
@@ -1884,7 +1884,7 @@
           <a:p>
             <a:fld id="{5BCAD085-E8A6-8845-BD4E-CB4CCA059FC4}" type="datetimeFigureOut">
               <a:rPr lang="en-US" smtClean="0"/>
-              <a:t>1/27/13</a:t>
+              <a:t>6/4/2026</a:t>
             </a:fld>
             <a:endParaRPr lang="en-US"/>
           </a:p>
@@ -1979,7 +1979,7 @@
           <a:p>
             <a:fld id="{5BCAD085-E8A6-8845-BD4E-CB4CCA059FC4}" type="datetimeFigureOut">
               <a:rPr lang="en-US" smtClean="0"/>
-              <a:t>1/27/13</a:t>
+              <a:t>6/4/2026</a:t>
             </a:fld>
             <a:endParaRPr lang="en-US"/>
           </a:p>
@@ -2082,10 +2082,9 @@
           </a:lstStyle>
           <a:p>
             <a:r>
-              <a:rPr lang="en-US" smtClean="0"/>
+              <a:rPr lang="en-US"/>
               <a:t>Click to edit Master title style</a:t>
             </a:r>
-            <a:endParaRPr lang="en-US"/>
           </a:p>
         </p:txBody>
       </p:sp>
@@ -2139,38 +2138,37 @@
           <a:p>
             <a:pPr lvl="0"/>
             <a:r>
-              <a:rPr lang="en-US" smtClean="0"/>
+              <a:rPr lang="en-US"/>
               <a:t>Click to edit Master text styles</a:t>
             </a:r>
           </a:p>
           <a:p>
             <a:pPr lvl="1"/>
             <a:r>
-              <a:rPr lang="en-US" smtClean="0"/>
+              <a:rPr lang="en-US"/>
               <a:t>Second level</a:t>
             </a:r>
           </a:p>
           <a:p>
             <a:pPr lvl="2"/>
             <a:r>
-              <a:rPr lang="en-US" smtClean="0"/>
+              <a:rPr lang="en-US"/>
               <a:t>Third level</a:t>
             </a:r>
           </a:p>
           <a:p>
             <a:pPr lvl="3"/>
             <a:r>
-              <a:rPr lang="en-US" smtClean="0"/>
+              <a:rPr lang="en-US"/>
               <a:t>Fourth level</a:t>
             </a:r>
           </a:p>
           <a:p>
             <a:pPr lvl="4"/>
             <a:r>
-              <a:rPr lang="en-US" smtClean="0"/>
+              <a:rPr lang="en-US"/>
               <a:t>Fifth level</a:t>
             </a:r>
-            <a:endParaRPr lang="en-US"/>
           </a:p>
         </p:txBody>
       </p:sp>
@@ -2233,7 +2231,7 @@
           <a:p>
             <a:pPr lvl="0"/>
             <a:r>
-              <a:rPr lang="en-US" smtClean="0"/>
+              <a:rPr lang="en-US"/>
               <a:t>Click to edit Master text styles</a:t>
             </a:r>
           </a:p>
@@ -2256,7 +2254,7 @@
           <a:p>
             <a:fld id="{5BCAD085-E8A6-8845-BD4E-CB4CCA059FC4}" type="datetimeFigureOut">
               <a:rPr lang="en-US" smtClean="0"/>
-              <a:t>1/27/13</a:t>
+              <a:t>6/4/2026</a:t>
             </a:fld>
             <a:endParaRPr lang="en-US"/>
           </a:p>
@@ -2359,10 +2357,9 @@
           </a:lstStyle>
           <a:p>
             <a:r>
-              <a:rPr lang="en-US" smtClean="0"/>
+              <a:rPr lang="en-US"/>
               <a:t>Click to edit Master title style</a:t>
             </a:r>
-            <a:endParaRPr lang="en-US"/>
           </a:p>
         </p:txBody>
       </p:sp>
@@ -2486,7 +2483,7 @@
           <a:p>
             <a:pPr lvl="0"/>
             <a:r>
-              <a:rPr lang="en-US" smtClean="0"/>
+              <a:rPr lang="en-US"/>
               <a:t>Click to edit Master text styles</a:t>
             </a:r>
           </a:p>
@@ -2509,7 +2506,7 @@
           <a:p>
             <a:fld id="{5BCAD085-E8A6-8845-BD4E-CB4CCA059FC4}" type="datetimeFigureOut">
               <a:rPr lang="en-US" smtClean="0"/>
-              <a:t>1/27/13</a:t>
+              <a:t>6/4/2026</a:t>
             </a:fld>
             <a:endParaRPr lang="en-US"/>
           </a:p>
@@ -2618,10 +2615,9 @@
           <a:lstStyle/>
           <a:p>
             <a:r>
-              <a:rPr lang="en-US" smtClean="0"/>
+              <a:rPr lang="en-US"/>
               <a:t>Click to edit Master title style</a:t>
             </a:r>
-            <a:endParaRPr lang="en-US"/>
           </a:p>
         </p:txBody>
       </p:sp>
@@ -2652,38 +2648,37 @@
           <a:p>
             <a:pPr lvl="0"/>
             <a:r>
-              <a:rPr lang="en-US" smtClean="0"/>
+              <a:rPr lang="en-US"/>
               <a:t>Click to edit Master text styles</a:t>
             </a:r>
           </a:p>
           <a:p>
             <a:pPr lvl="1"/>
             <a:r>
-              <a:rPr lang="en-US" smtClean="0"/>
+              <a:rPr lang="en-US"/>
               <a:t>Second level</a:t>
             </a:r>
           </a:p>
           <a:p>
             <a:pPr lvl="2"/>
             <a:r>
-              <a:rPr lang="en-US" smtClean="0"/>
+              <a:rPr lang="en-US"/>
               <a:t>Third level</a:t>
             </a:r>
           </a:p>
           <a:p>
             <a:pPr lvl="3"/>
             <a:r>
-              <a:rPr lang="en-US" smtClean="0"/>
+              <a:rPr lang="en-US"/>
               <a:t>Fourth level</a:t>
             </a:r>
           </a:p>
           <a:p>
             <a:pPr lvl="4"/>
             <a:r>
-              <a:rPr lang="en-US" smtClean="0"/>
+              <a:rPr lang="en-US"/>
               <a:t>Fifth level</a:t>
             </a:r>
-            <a:endParaRPr lang="en-US"/>
           </a:p>
         </p:txBody>
       </p:sp>
@@ -2722,7 +2717,7 @@
           <a:p>
             <a:fld id="{5BCAD085-E8A6-8845-BD4E-CB4CCA059FC4}" type="datetimeFigureOut">
               <a:rPr lang="en-US" smtClean="0"/>
-              <a:t>1/27/13</a:t>
+              <a:t>6/4/2026</a:t>
             </a:fld>
             <a:endParaRPr lang="en-US"/>
           </a:p>
@@ -3081,7 +3076,7 @@
 </file>
 
 <file path=ppt/slides/slide1.xml><?xml version="1.0" encoding="utf-8"?>
-<p:sld xmlns:a="http://schemas.openxmlformats.org/drawingml/2006/main" xmlns:p="http://schemas.openxmlformats.org/presentationml/2006/main" xmlns:r="http://schemas.openxmlformats.org/officeDocument/2006/relationships">
+<p:sld xmlns:a="http://schemas.openxmlformats.org/drawingml/2006/main" xmlns:r="http://schemas.openxmlformats.org/officeDocument/2006/relationships" xmlns:p="http://schemas.openxmlformats.org/presentationml/2006/main">
   <p:cSld>
     <p:spTree>
       <p:nvGrpSpPr>
@@ -3089,7 +3084,14 @@
         <p:cNvGrpSpPr/>
         <p:nvPr/>
       </p:nvGrpSpPr>
-      <p:grpSpPr/>
+      <p:grpSpPr>
+        <a:xfrm>
+          <a:off x="0" y="0"/>
+          <a:ext cx="0" cy="0"/>
+          <a:chOff x="0" y="0"/>
+          <a:chExt cx="0" cy="0"/>
+        </a:xfrm>
+      </p:grpSpPr>
       <p:sp>
         <p:nvSpPr>
           <p:cNvPr id="2" name="Title 1"/>
@@ -3102,10 +3104,15 @@
         </p:nvSpPr>
         <p:spPr/>
         <p:txBody>
-          <a:bodyPr/>
-          <a:lstStyle/>
-          <a:p>
-            <a:r>
+          <a:bodyPr>
+            <a:normAutofit/>
+          </a:bodyPr>
+          <a:lstStyle/>
+          <a:p>
+            <a:r>
+              <a:rPr sz="1600">
+                <a:latin typeface="宋体" panose="02010600030101010101" pitchFamily="2" charset="-122"/>
+              </a:rPr>
               <a:t>Sample Presentation</a:t>
             </a:r>
           </a:p>
@@ -3123,10 +3130,15 @@
         </p:nvSpPr>
         <p:spPr/>
         <p:txBody>
-          <a:bodyPr/>
-          <a:lstStyle/>
-          <a:p>
-            <a:r>
+          <a:bodyPr>
+            <a:normAutofit/>
+          </a:bodyPr>
+          <a:lstStyle/>
+          <a:p>
+            <a:r>
+              <a:rPr sz="1600">
+                <a:latin typeface="宋体" panose="02010600030101010101" pitchFamily="2" charset="-122"/>
+              </a:rPr>
               <a:t>For testing pptx_editor_llm.py</a:t>
             </a:r>
           </a:p>
@@ -3141,7 +3153,7 @@
 </file>
 
 <file path=ppt/slides/slide2.xml><?xml version="1.0" encoding="utf-8"?>
-<p:sld xmlns:a="http://schemas.openxmlformats.org/drawingml/2006/main" xmlns:p="http://schemas.openxmlformats.org/presentationml/2006/main" xmlns:r="http://schemas.openxmlformats.org/officeDocument/2006/relationships">
+<p:sld xmlns:a="http://schemas.openxmlformats.org/drawingml/2006/main" xmlns:r="http://schemas.openxmlformats.org/officeDocument/2006/relationships" xmlns:p="http://schemas.openxmlformats.org/presentationml/2006/main">
   <p:cSld>
     <p:spTree>
       <p:nvGrpSpPr>
@@ -3149,7 +3161,14 @@
         <p:cNvGrpSpPr/>
         <p:nvPr/>
       </p:nvGrpSpPr>
-      <p:grpSpPr/>
+      <p:grpSpPr>
+        <a:xfrm>
+          <a:off x="0" y="0"/>
+          <a:ext cx="0" cy="0"/>
+          <a:chOff x="0" y="0"/>
+          <a:chExt cx="0" cy="0"/>
+        </a:xfrm>
+      </p:grpSpPr>
       <p:sp>
         <p:nvSpPr>
           <p:cNvPr id="2" name="Title 1"/>
@@ -3162,10 +3181,15 @@
         </p:nvSpPr>
         <p:spPr/>
         <p:txBody>
-          <a:bodyPr/>
-          <a:lstStyle/>
-          <a:p>
-            <a:r>
+          <a:bodyPr>
+            <a:normAutofit/>
+          </a:bodyPr>
+          <a:lstStyle/>
+          <a:p>
+            <a:r>
+              <a:rPr sz="1600">
+                <a:latin typeface="宋体" panose="02010600030101010101" pitchFamily="2" charset="-122"/>
+              </a:rPr>
               <a:t>Key Points</a:t>
             </a:r>
           </a:p>
@@ -3183,20 +3207,31 @@
         </p:nvSpPr>
         <p:spPr/>
         <p:txBody>
-          <a:bodyPr/>
-          <a:lstStyle/>
-          <a:p>
-            <a:r>
+          <a:bodyPr>
+            <a:normAutofit/>
+          </a:bodyPr>
+          <a:lstStyle/>
+          <a:p>
+            <a:r>
+              <a:rPr sz="1600">
+                <a:latin typeface="宋体" panose="02010600030101010101" pitchFamily="2" charset="-122"/>
+              </a:rPr>
               <a:t>First point</a:t>
             </a:r>
           </a:p>
           <a:p>
             <a:r>
+              <a:rPr sz="1600">
+                <a:latin typeface="宋体" panose="02010600030101010101" pitchFamily="2" charset="-122"/>
+              </a:rPr>
               <a:t>Second point</a:t>
             </a:r>
           </a:p>
           <a:p>
             <a:r>
+              <a:rPr sz="1600">
+                <a:latin typeface="宋体" panose="02010600030101010101" pitchFamily="2" charset="-122"/>
+              </a:rPr>
               <a:t>Third point</a:t>
             </a:r>
           </a:p>
@@ -3211,7 +3246,7 @@
 </file>
 
 <file path=ppt/slides/slide3.xml><?xml version="1.0" encoding="utf-8"?>
-<p:sld xmlns:a="http://schemas.openxmlformats.org/drawingml/2006/main" xmlns:p="http://schemas.openxmlformats.org/presentationml/2006/main" xmlns:r="http://schemas.openxmlformats.org/officeDocument/2006/relationships">
+<p:sld xmlns:a="http://schemas.openxmlformats.org/drawingml/2006/main" xmlns:r="http://schemas.openxmlformats.org/officeDocument/2006/relationships" xmlns:p="http://schemas.openxmlformats.org/presentationml/2006/main">
   <p:cSld>
     <p:spTree>
       <p:nvGrpSpPr>
@@ -3219,7 +3254,14 @@
         <p:cNvGrpSpPr/>
         <p:nvPr/>
       </p:nvGrpSpPr>
-      <p:grpSpPr/>
+      <p:grpSpPr>
+        <a:xfrm>
+          <a:off x="0" y="0"/>
+          <a:ext cx="0" cy="0"/>
+          <a:chOff x="0" y="0"/>
+          <a:chExt cx="0" cy="0"/>
+        </a:xfrm>
+      </p:grpSpPr>
       <p:sp>
         <p:nvSpPr>
           <p:cNvPr id="2" name="TextBox 1"/>
@@ -3229,7 +3271,7 @@
         <p:spPr>
           <a:xfrm>
             <a:off x="914400" y="914400"/>
-            <a:ext cx="7315200" cy="1828800"/>
+            <a:ext cx="4698722" cy="338554"/>
           </a:xfrm>
           <a:prstGeom prst="rect">
             <a:avLst/>
@@ -3243,6 +3285,9 @@
           <a:lstStyle/>
           <a:p>
             <a:r>
+              <a:rPr sz="1600">
+                <a:latin typeface="宋体" panose="02010600030101010101" pitchFamily="2" charset="-122"/>
+              </a:rPr>
               <a:t>Edit me with --exec-script or --exec-actions</a:t>
             </a:r>
           </a:p>
@@ -3574,4 +3619,10 @@
   </a:objectDefaults>
   <a:extraClrSchemeLst/>
 </a:theme>
+</file>
+
+<file path=docMetadata/LabelInfo.xml><?xml version="1.0" encoding="utf-8"?>
+<clbl:labelList xmlns:clbl="http://schemas.microsoft.com/office/2020/mipLabelMetadata">
+  <clbl:label id="{f42aa342-8706-4288-bd11-ebb85995028c}" enabled="1" method="Standard" siteId="{72f988bf-86f1-41af-91ab-2d7cd011db47}" contentBits="0" removed="0"/>
+</clbl:labelList>
 </file>
</xml_diff>